<commit_message>
This is a bucket
</commit_message>
<xml_diff>
--- a/SIpos Kristóf/eretségi gyakorlás/2026_Tavasz/napozas.pptx
+++ b/SIpos Kristóf/eretségi gyakorlás/2026_Tavasz/napozas.pptx
@@ -249,7 +249,7 @@
           <a:p>
             <a:fld id="{F5F1901C-D33B-4565-A7E4-5DF903098DB6}" type="datetimeFigureOut">
               <a:rPr lang="hu-HU" smtClean="0"/>
-              <a:t>2026. 09. 20.</a:t>
+              <a:t>2026. 09. 21.</a:t>
             </a:fld>
             <a:endParaRPr lang="hu-HU"/>
           </a:p>
@@ -417,7 +417,7 @@
           <a:p>
             <a:fld id="{F5F1901C-D33B-4565-A7E4-5DF903098DB6}" type="datetimeFigureOut">
               <a:rPr lang="hu-HU" smtClean="0"/>
-              <a:t>2026. 09. 20.</a:t>
+              <a:t>2026. 09. 21.</a:t>
             </a:fld>
             <a:endParaRPr lang="hu-HU"/>
           </a:p>
@@ -595,7 +595,7 @@
           <a:p>
             <a:fld id="{F5F1901C-D33B-4565-A7E4-5DF903098DB6}" type="datetimeFigureOut">
               <a:rPr lang="hu-HU" smtClean="0"/>
-              <a:t>2026. 09. 20.</a:t>
+              <a:t>2026. 09. 21.</a:t>
             </a:fld>
             <a:endParaRPr lang="hu-HU"/>
           </a:p>
@@ -763,7 +763,7 @@
           <a:p>
             <a:fld id="{F5F1901C-D33B-4565-A7E4-5DF903098DB6}" type="datetimeFigureOut">
               <a:rPr lang="hu-HU" smtClean="0"/>
-              <a:t>2026. 09. 20.</a:t>
+              <a:t>2026. 09. 21.</a:t>
             </a:fld>
             <a:endParaRPr lang="hu-HU"/>
           </a:p>
@@ -1008,7 +1008,7 @@
           <a:p>
             <a:fld id="{F5F1901C-D33B-4565-A7E4-5DF903098DB6}" type="datetimeFigureOut">
               <a:rPr lang="hu-HU" smtClean="0"/>
-              <a:t>2026. 09. 20.</a:t>
+              <a:t>2026. 09. 21.</a:t>
             </a:fld>
             <a:endParaRPr lang="hu-HU"/>
           </a:p>
@@ -1237,7 +1237,7 @@
           <a:p>
             <a:fld id="{F5F1901C-D33B-4565-A7E4-5DF903098DB6}" type="datetimeFigureOut">
               <a:rPr lang="hu-HU" smtClean="0"/>
-              <a:t>2026. 09. 20.</a:t>
+              <a:t>2026. 09. 21.</a:t>
             </a:fld>
             <a:endParaRPr lang="hu-HU"/>
           </a:p>
@@ -1601,7 +1601,7 @@
           <a:p>
             <a:fld id="{F5F1901C-D33B-4565-A7E4-5DF903098DB6}" type="datetimeFigureOut">
               <a:rPr lang="hu-HU" smtClean="0"/>
-              <a:t>2026. 09. 20.</a:t>
+              <a:t>2026. 09. 21.</a:t>
             </a:fld>
             <a:endParaRPr lang="hu-HU"/>
           </a:p>
@@ -1718,7 +1718,7 @@
           <a:p>
             <a:fld id="{F5F1901C-D33B-4565-A7E4-5DF903098DB6}" type="datetimeFigureOut">
               <a:rPr lang="hu-HU" smtClean="0"/>
-              <a:t>2026. 09. 20.</a:t>
+              <a:t>2026. 09. 21.</a:t>
             </a:fld>
             <a:endParaRPr lang="hu-HU"/>
           </a:p>
@@ -1813,7 +1813,7 @@
           <a:p>
             <a:fld id="{F5F1901C-D33B-4565-A7E4-5DF903098DB6}" type="datetimeFigureOut">
               <a:rPr lang="hu-HU" smtClean="0"/>
-              <a:t>2026. 09. 20.</a:t>
+              <a:t>2026. 09. 21.</a:t>
             </a:fld>
             <a:endParaRPr lang="hu-HU"/>
           </a:p>
@@ -2088,7 +2088,7 @@
           <a:p>
             <a:fld id="{F5F1901C-D33B-4565-A7E4-5DF903098DB6}" type="datetimeFigureOut">
               <a:rPr lang="hu-HU" smtClean="0"/>
-              <a:t>2026. 09. 20.</a:t>
+              <a:t>2026. 09. 21.</a:t>
             </a:fld>
             <a:endParaRPr lang="hu-HU"/>
           </a:p>
@@ -2340,7 +2340,7 @@
           <a:p>
             <a:fld id="{F5F1901C-D33B-4565-A7E4-5DF903098DB6}" type="datetimeFigureOut">
               <a:rPr lang="hu-HU" smtClean="0"/>
-              <a:t>2026. 09. 20.</a:t>
+              <a:t>2026. 09. 21.</a:t>
             </a:fld>
             <a:endParaRPr lang="hu-HU"/>
           </a:p>
@@ -2551,7 +2551,7 @@
           <a:p>
             <a:fld id="{F5F1901C-D33B-4565-A7E4-5DF903098DB6}" type="datetimeFigureOut">
               <a:rPr lang="hu-HU" smtClean="0"/>
-              <a:t>2026. 09. 20.</a:t>
+              <a:t>2026. 09. 21.</a:t>
             </a:fld>
             <a:endParaRPr lang="hu-HU"/>
           </a:p>
@@ -3026,7 +3026,7 @@
           </a:p>
           <a:p>
             <a:pPr algn="ctr"/>
-            <a:endParaRPr lang="en-US"/>
+            <a:endParaRPr lang="en-US" dirty="0"/>
           </a:p>
         </p:txBody>
       </p:sp>
@@ -3357,14 +3357,6 @@
                 </a:rPr>
                 <a:t>Kerüld</a:t>
               </a:r>
-              <a:endParaRPr lang="en-US" sz="2800">
-                <a:solidFill>
-                  <a:schemeClr val="bg1"/>
-                </a:solidFill>
-                <a:latin typeface="Open Sans"/>
-                <a:ea typeface="Open Sans"/>
-                <a:cs typeface="Open Sans"/>
-              </a:endParaRPr>
             </a:p>
             <a:p>
               <a:r>
@@ -3381,7 +3373,7 @@
             </a:p>
             <a:p>
               <a:pPr algn="ctr"/>
-              <a:endParaRPr lang="en-US"/>
+              <a:endParaRPr lang="en-US" dirty="0"/>
             </a:p>
           </p:txBody>
         </p:sp>

</xml_diff>